<commit_message>
Code David + filt sorted
</commit_message>
<xml_diff>
--- a/outputs/presentation/var_presentation.pptx
+++ b/outputs/presentation/var_presentation.pptx
@@ -5,21 +5,21 @@
     <p:sldMasterId id="2147483648" r:id="rId1"/>
   </p:sldMasterIdLst>
   <p:sldIdLst>
-    <p:sldId id="256" r:id="rId7"/>
-    <p:sldId id="257" r:id="rId8"/>
-    <p:sldId id="258" r:id="rId9"/>
-    <p:sldId id="259" r:id="rId10"/>
-    <p:sldId id="260" r:id="rId11"/>
-    <p:sldId id="261" r:id="rId12"/>
-    <p:sldId id="262" r:id="rId13"/>
-    <p:sldId id="263" r:id="rId14"/>
-    <p:sldId id="264" r:id="rId15"/>
-    <p:sldId id="265" r:id="rId16"/>
-    <p:sldId id="266" r:id="rId17"/>
-    <p:sldId id="267" r:id="rId18"/>
-    <p:sldId id="268" r:id="rId19"/>
+    <p:sldId id="256" r:id="rId2"/>
+    <p:sldId id="257" r:id="rId3"/>
+    <p:sldId id="258" r:id="rId4"/>
+    <p:sldId id="259" r:id="rId5"/>
+    <p:sldId id="260" r:id="rId6"/>
+    <p:sldId id="261" r:id="rId7"/>
+    <p:sldId id="262" r:id="rId8"/>
+    <p:sldId id="263" r:id="rId9"/>
+    <p:sldId id="264" r:id="rId10"/>
+    <p:sldId id="265" r:id="rId11"/>
+    <p:sldId id="266" r:id="rId12"/>
+    <p:sldId id="267" r:id="rId13"/>
+    <p:sldId id="268" r:id="rId14"/>
   </p:sldIdLst>
-  <p:sldSz cx="9144000" cy="5143500" type="screen4x3"/>
+  <p:sldSz cx="9144000" cy="5143500" type="screen16x9"/>
   <p:notesSz cx="6858000" cy="9144000"/>
   <p:defaultTextStyle>
     <a:defPPr>
@@ -116,6 +116,22 @@
       </a:defRPr>
     </a:lvl9pPr>
   </p:defaultTextStyle>
+  <p:extLst>
+    <p:ext uri="{EFAFB233-063F-42B5-8137-9DF3F51BA10A}">
+      <p15:sldGuideLst xmlns:p15="http://schemas.microsoft.com/office/powerpoint/2012/main">
+        <p15:guide id="1" orient="horz" pos="2160">
+          <p15:clr>
+            <a:srgbClr val="A4A3A4"/>
+          </p15:clr>
+        </p15:guide>
+        <p15:guide id="2" pos="2880">
+          <p15:clr>
+            <a:srgbClr val="A4A3A4"/>
+          </p15:clr>
+        </p15:guide>
+      </p15:sldGuideLst>
+    </p:ext>
+  </p:extLst>
 </p:presentation>
 </file>
 
@@ -157,10 +173,9 @@
           <a:lstStyle/>
           <a:p>
             <a:r>
-              <a:rPr lang="en-US" smtClean="0"/>
+              <a:rPr lang="en-US"/>
               <a:t>Click to edit Master title style</a:t>
             </a:r>
-            <a:endParaRPr lang="en-US"/>
           </a:p>
         </p:txBody>
       </p:sp>
@@ -276,10 +291,9 @@
           </a:lstStyle>
           <a:p>
             <a:r>
-              <a:rPr lang="en-US" smtClean="0"/>
+              <a:rPr lang="en-US"/>
               <a:t>Click to edit Master subtitle style</a:t>
             </a:r>
-            <a:endParaRPr lang="en-US"/>
           </a:p>
         </p:txBody>
       </p:sp>
@@ -300,7 +314,7 @@
           <a:p>
             <a:fld id="{5BCAD085-E8A6-8845-BD4E-CB4CCA059FC4}" type="datetimeFigureOut">
               <a:rPr lang="en-US" smtClean="0"/>
-              <a:t>1/27/13</a:t>
+              <a:t>5/5/2026</a:t>
             </a:fld>
             <a:endParaRPr lang="en-US"/>
           </a:p>
@@ -394,10 +408,9 @@
           <a:lstStyle/>
           <a:p>
             <a:r>
-              <a:rPr lang="en-US" smtClean="0"/>
+              <a:rPr lang="en-US"/>
               <a:t>Click to edit Master title style</a:t>
             </a:r>
-            <a:endParaRPr lang="en-US"/>
           </a:p>
         </p:txBody>
       </p:sp>
@@ -418,38 +431,37 @@
           <a:p>
             <a:pPr lvl="0"/>
             <a:r>
-              <a:rPr lang="en-US" smtClean="0"/>
+              <a:rPr lang="en-US"/>
               <a:t>Click to edit Master text styles</a:t>
             </a:r>
           </a:p>
           <a:p>
             <a:pPr lvl="1"/>
             <a:r>
-              <a:rPr lang="en-US" smtClean="0"/>
+              <a:rPr lang="en-US"/>
               <a:t>Second level</a:t>
             </a:r>
           </a:p>
           <a:p>
             <a:pPr lvl="2"/>
             <a:r>
-              <a:rPr lang="en-US" smtClean="0"/>
+              <a:rPr lang="en-US"/>
               <a:t>Third level</a:t>
             </a:r>
           </a:p>
           <a:p>
             <a:pPr lvl="3"/>
             <a:r>
-              <a:rPr lang="en-US" smtClean="0"/>
+              <a:rPr lang="en-US"/>
               <a:t>Fourth level</a:t>
             </a:r>
           </a:p>
           <a:p>
             <a:pPr lvl="4"/>
             <a:r>
-              <a:rPr lang="en-US" smtClean="0"/>
+              <a:rPr lang="en-US"/>
               <a:t>Fifth level</a:t>
             </a:r>
-            <a:endParaRPr lang="en-US"/>
           </a:p>
         </p:txBody>
       </p:sp>
@@ -470,7 +482,7 @@
           <a:p>
             <a:fld id="{5BCAD085-E8A6-8845-BD4E-CB4CCA059FC4}" type="datetimeFigureOut">
               <a:rPr lang="en-US" smtClean="0"/>
-              <a:t>1/27/13</a:t>
+              <a:t>5/5/2026</a:t>
             </a:fld>
             <a:endParaRPr lang="en-US"/>
           </a:p>
@@ -569,10 +581,9 @@
           <a:lstStyle/>
           <a:p>
             <a:r>
-              <a:rPr lang="en-US" smtClean="0"/>
+              <a:rPr lang="en-US"/>
               <a:t>Click to edit Master title style</a:t>
             </a:r>
-            <a:endParaRPr lang="en-US"/>
           </a:p>
         </p:txBody>
       </p:sp>
@@ -598,38 +609,37 @@
           <a:p>
             <a:pPr lvl="0"/>
             <a:r>
-              <a:rPr lang="en-US" smtClean="0"/>
+              <a:rPr lang="en-US"/>
               <a:t>Click to edit Master text styles</a:t>
             </a:r>
           </a:p>
           <a:p>
             <a:pPr lvl="1"/>
             <a:r>
-              <a:rPr lang="en-US" smtClean="0"/>
+              <a:rPr lang="en-US"/>
               <a:t>Second level</a:t>
             </a:r>
           </a:p>
           <a:p>
             <a:pPr lvl="2"/>
             <a:r>
-              <a:rPr lang="en-US" smtClean="0"/>
+              <a:rPr lang="en-US"/>
               <a:t>Third level</a:t>
             </a:r>
           </a:p>
           <a:p>
             <a:pPr lvl="3"/>
             <a:r>
-              <a:rPr lang="en-US" smtClean="0"/>
+              <a:rPr lang="en-US"/>
               <a:t>Fourth level</a:t>
             </a:r>
           </a:p>
           <a:p>
             <a:pPr lvl="4"/>
             <a:r>
-              <a:rPr lang="en-US" smtClean="0"/>
+              <a:rPr lang="en-US"/>
               <a:t>Fifth level</a:t>
             </a:r>
-            <a:endParaRPr lang="en-US"/>
           </a:p>
         </p:txBody>
       </p:sp>
@@ -650,7 +660,7 @@
           <a:p>
             <a:fld id="{5BCAD085-E8A6-8845-BD4E-CB4CCA059FC4}" type="datetimeFigureOut">
               <a:rPr lang="en-US" smtClean="0"/>
-              <a:t>1/27/13</a:t>
+              <a:t>5/5/2026</a:t>
             </a:fld>
             <a:endParaRPr lang="en-US"/>
           </a:p>
@@ -744,10 +754,9 @@
           <a:lstStyle/>
           <a:p>
             <a:r>
-              <a:rPr lang="en-US" smtClean="0"/>
+              <a:rPr lang="en-US"/>
               <a:t>Click to edit Master title style</a:t>
             </a:r>
-            <a:endParaRPr lang="en-US"/>
           </a:p>
         </p:txBody>
       </p:sp>
@@ -768,38 +777,37 @@
           <a:p>
             <a:pPr lvl="0"/>
             <a:r>
-              <a:rPr lang="en-US" smtClean="0"/>
+              <a:rPr lang="en-US"/>
               <a:t>Click to edit Master text styles</a:t>
             </a:r>
           </a:p>
           <a:p>
             <a:pPr lvl="1"/>
             <a:r>
-              <a:rPr lang="en-US" smtClean="0"/>
+              <a:rPr lang="en-US"/>
               <a:t>Second level</a:t>
             </a:r>
           </a:p>
           <a:p>
             <a:pPr lvl="2"/>
             <a:r>
-              <a:rPr lang="en-US" smtClean="0"/>
+              <a:rPr lang="en-US"/>
               <a:t>Third level</a:t>
             </a:r>
           </a:p>
           <a:p>
             <a:pPr lvl="3"/>
             <a:r>
-              <a:rPr lang="en-US" smtClean="0"/>
+              <a:rPr lang="en-US"/>
               <a:t>Fourth level</a:t>
             </a:r>
           </a:p>
           <a:p>
             <a:pPr lvl="4"/>
             <a:r>
-              <a:rPr lang="en-US" smtClean="0"/>
+              <a:rPr lang="en-US"/>
               <a:t>Fifth level</a:t>
             </a:r>
-            <a:endParaRPr lang="en-US"/>
           </a:p>
         </p:txBody>
       </p:sp>
@@ -820,7 +828,7 @@
           <a:p>
             <a:fld id="{5BCAD085-E8A6-8845-BD4E-CB4CCA059FC4}" type="datetimeFigureOut">
               <a:rPr lang="en-US" smtClean="0"/>
-              <a:t>1/27/13</a:t>
+              <a:t>5/5/2026</a:t>
             </a:fld>
             <a:endParaRPr lang="en-US"/>
           </a:p>
@@ -923,10 +931,9 @@
           </a:lstStyle>
           <a:p>
             <a:r>
-              <a:rPr lang="en-US" smtClean="0"/>
+              <a:rPr lang="en-US"/>
               <a:t>Click to edit Master title style</a:t>
             </a:r>
-            <a:endParaRPr lang="en-US"/>
           </a:p>
         </p:txBody>
       </p:sp>
@@ -1043,7 +1050,7 @@
           <a:p>
             <a:pPr lvl="0"/>
             <a:r>
-              <a:rPr lang="en-US" smtClean="0"/>
+              <a:rPr lang="en-US"/>
               <a:t>Click to edit Master text styles</a:t>
             </a:r>
           </a:p>
@@ -1066,7 +1073,7 @@
           <a:p>
             <a:fld id="{5BCAD085-E8A6-8845-BD4E-CB4CCA059FC4}" type="datetimeFigureOut">
               <a:rPr lang="en-US" smtClean="0"/>
-              <a:t>1/27/13</a:t>
+              <a:t>5/5/2026</a:t>
             </a:fld>
             <a:endParaRPr lang="en-US"/>
           </a:p>
@@ -1160,10 +1167,9 @@
           <a:lstStyle/>
           <a:p>
             <a:r>
-              <a:rPr lang="en-US" smtClean="0"/>
+              <a:rPr lang="en-US"/>
               <a:t>Click to edit Master title style</a:t>
             </a:r>
-            <a:endParaRPr lang="en-US"/>
           </a:p>
         </p:txBody>
       </p:sp>
@@ -1217,38 +1223,37 @@
           <a:p>
             <a:pPr lvl="0"/>
             <a:r>
-              <a:rPr lang="en-US" smtClean="0"/>
+              <a:rPr lang="en-US"/>
               <a:t>Click to edit Master text styles</a:t>
             </a:r>
           </a:p>
           <a:p>
             <a:pPr lvl="1"/>
             <a:r>
-              <a:rPr lang="en-US" smtClean="0"/>
+              <a:rPr lang="en-US"/>
               <a:t>Second level</a:t>
             </a:r>
           </a:p>
           <a:p>
             <a:pPr lvl="2"/>
             <a:r>
-              <a:rPr lang="en-US" smtClean="0"/>
+              <a:rPr lang="en-US"/>
               <a:t>Third level</a:t>
             </a:r>
           </a:p>
           <a:p>
             <a:pPr lvl="3"/>
             <a:r>
-              <a:rPr lang="en-US" smtClean="0"/>
+              <a:rPr lang="en-US"/>
               <a:t>Fourth level</a:t>
             </a:r>
           </a:p>
           <a:p>
             <a:pPr lvl="4"/>
             <a:r>
-              <a:rPr lang="en-US" smtClean="0"/>
+              <a:rPr lang="en-US"/>
               <a:t>Fifth level</a:t>
             </a:r>
-            <a:endParaRPr lang="en-US"/>
           </a:p>
         </p:txBody>
       </p:sp>
@@ -1302,38 +1307,37 @@
           <a:p>
             <a:pPr lvl="0"/>
             <a:r>
-              <a:rPr lang="en-US" smtClean="0"/>
+              <a:rPr lang="en-US"/>
               <a:t>Click to edit Master text styles</a:t>
             </a:r>
           </a:p>
           <a:p>
             <a:pPr lvl="1"/>
             <a:r>
-              <a:rPr lang="en-US" smtClean="0"/>
+              <a:rPr lang="en-US"/>
               <a:t>Second level</a:t>
             </a:r>
           </a:p>
           <a:p>
             <a:pPr lvl="2"/>
             <a:r>
-              <a:rPr lang="en-US" smtClean="0"/>
+              <a:rPr lang="en-US"/>
               <a:t>Third level</a:t>
             </a:r>
           </a:p>
           <a:p>
             <a:pPr lvl="3"/>
             <a:r>
-              <a:rPr lang="en-US" smtClean="0"/>
+              <a:rPr lang="en-US"/>
               <a:t>Fourth level</a:t>
             </a:r>
           </a:p>
           <a:p>
             <a:pPr lvl="4"/>
             <a:r>
-              <a:rPr lang="en-US" smtClean="0"/>
+              <a:rPr lang="en-US"/>
               <a:t>Fifth level</a:t>
             </a:r>
-            <a:endParaRPr lang="en-US"/>
           </a:p>
         </p:txBody>
       </p:sp>
@@ -1354,7 +1358,7 @@
           <a:p>
             <a:fld id="{5BCAD085-E8A6-8845-BD4E-CB4CCA059FC4}" type="datetimeFigureOut">
               <a:rPr lang="en-US" smtClean="0"/>
-              <a:t>1/27/13</a:t>
+              <a:t>5/5/2026</a:t>
             </a:fld>
             <a:endParaRPr lang="en-US"/>
           </a:p>
@@ -1452,10 +1456,9 @@
           </a:lstStyle>
           <a:p>
             <a:r>
-              <a:rPr lang="en-US" smtClean="0"/>
+              <a:rPr lang="en-US"/>
               <a:t>Click to edit Master title style</a:t>
             </a:r>
-            <a:endParaRPr lang="en-US"/>
           </a:p>
         </p:txBody>
       </p:sp>
@@ -1518,7 +1521,7 @@
           <a:p>
             <a:pPr lvl="0"/>
             <a:r>
-              <a:rPr lang="en-US" smtClean="0"/>
+              <a:rPr lang="en-US"/>
               <a:t>Click to edit Master text styles</a:t>
             </a:r>
           </a:p>
@@ -1574,38 +1577,37 @@
           <a:p>
             <a:pPr lvl="0"/>
             <a:r>
-              <a:rPr lang="en-US" smtClean="0"/>
+              <a:rPr lang="en-US"/>
               <a:t>Click to edit Master text styles</a:t>
             </a:r>
           </a:p>
           <a:p>
             <a:pPr lvl="1"/>
             <a:r>
-              <a:rPr lang="en-US" smtClean="0"/>
+              <a:rPr lang="en-US"/>
               <a:t>Second level</a:t>
             </a:r>
           </a:p>
           <a:p>
             <a:pPr lvl="2"/>
             <a:r>
-              <a:rPr lang="en-US" smtClean="0"/>
+              <a:rPr lang="en-US"/>
               <a:t>Third level</a:t>
             </a:r>
           </a:p>
           <a:p>
             <a:pPr lvl="3"/>
             <a:r>
-              <a:rPr lang="en-US" smtClean="0"/>
+              <a:rPr lang="en-US"/>
               <a:t>Fourth level</a:t>
             </a:r>
           </a:p>
           <a:p>
             <a:pPr lvl="4"/>
             <a:r>
-              <a:rPr lang="en-US" smtClean="0"/>
+              <a:rPr lang="en-US"/>
               <a:t>Fifth level</a:t>
             </a:r>
-            <a:endParaRPr lang="en-US"/>
           </a:p>
         </p:txBody>
       </p:sp>
@@ -1668,7 +1670,7 @@
           <a:p>
             <a:pPr lvl="0"/>
             <a:r>
-              <a:rPr lang="en-US" smtClean="0"/>
+              <a:rPr lang="en-US"/>
               <a:t>Click to edit Master text styles</a:t>
             </a:r>
           </a:p>
@@ -1724,38 +1726,37 @@
           <a:p>
             <a:pPr lvl="0"/>
             <a:r>
-              <a:rPr lang="en-US" smtClean="0"/>
+              <a:rPr lang="en-US"/>
               <a:t>Click to edit Master text styles</a:t>
             </a:r>
           </a:p>
           <a:p>
             <a:pPr lvl="1"/>
             <a:r>
-              <a:rPr lang="en-US" smtClean="0"/>
+              <a:rPr lang="en-US"/>
               <a:t>Second level</a:t>
             </a:r>
           </a:p>
           <a:p>
             <a:pPr lvl="2"/>
             <a:r>
-              <a:rPr lang="en-US" smtClean="0"/>
+              <a:rPr lang="en-US"/>
               <a:t>Third level</a:t>
             </a:r>
           </a:p>
           <a:p>
             <a:pPr lvl="3"/>
             <a:r>
-              <a:rPr lang="en-US" smtClean="0"/>
+              <a:rPr lang="en-US"/>
               <a:t>Fourth level</a:t>
             </a:r>
           </a:p>
           <a:p>
             <a:pPr lvl="4"/>
             <a:r>
-              <a:rPr lang="en-US" smtClean="0"/>
+              <a:rPr lang="en-US"/>
               <a:t>Fifth level</a:t>
             </a:r>
-            <a:endParaRPr lang="en-US"/>
           </a:p>
         </p:txBody>
       </p:sp>
@@ -1776,7 +1777,7 @@
           <a:p>
             <a:fld id="{5BCAD085-E8A6-8845-BD4E-CB4CCA059FC4}" type="datetimeFigureOut">
               <a:rPr lang="en-US" smtClean="0"/>
-              <a:t>1/27/13</a:t>
+              <a:t>5/5/2026</a:t>
             </a:fld>
             <a:endParaRPr lang="en-US"/>
           </a:p>
@@ -1870,10 +1871,9 @@
           <a:lstStyle/>
           <a:p>
             <a:r>
-              <a:rPr lang="en-US" smtClean="0"/>
+              <a:rPr lang="en-US"/>
               <a:t>Click to edit Master title style</a:t>
             </a:r>
-            <a:endParaRPr lang="en-US"/>
           </a:p>
         </p:txBody>
       </p:sp>
@@ -1894,7 +1894,7 @@
           <a:p>
             <a:fld id="{5BCAD085-E8A6-8845-BD4E-CB4CCA059FC4}" type="datetimeFigureOut">
               <a:rPr lang="en-US" smtClean="0"/>
-              <a:t>1/27/13</a:t>
+              <a:t>5/5/2026</a:t>
             </a:fld>
             <a:endParaRPr lang="en-US"/>
           </a:p>
@@ -1989,7 +1989,7 @@
           <a:p>
             <a:fld id="{5BCAD085-E8A6-8845-BD4E-CB4CCA059FC4}" type="datetimeFigureOut">
               <a:rPr lang="en-US" smtClean="0"/>
-              <a:t>1/27/13</a:t>
+              <a:t>5/5/2026</a:t>
             </a:fld>
             <a:endParaRPr lang="en-US"/>
           </a:p>
@@ -2092,10 +2092,9 @@
           </a:lstStyle>
           <a:p>
             <a:r>
-              <a:rPr lang="en-US" smtClean="0"/>
+              <a:rPr lang="en-US"/>
               <a:t>Click to edit Master title style</a:t>
             </a:r>
-            <a:endParaRPr lang="en-US"/>
           </a:p>
         </p:txBody>
       </p:sp>
@@ -2149,38 +2148,37 @@
           <a:p>
             <a:pPr lvl="0"/>
             <a:r>
-              <a:rPr lang="en-US" smtClean="0"/>
+              <a:rPr lang="en-US"/>
               <a:t>Click to edit Master text styles</a:t>
             </a:r>
           </a:p>
           <a:p>
             <a:pPr lvl="1"/>
             <a:r>
-              <a:rPr lang="en-US" smtClean="0"/>
+              <a:rPr lang="en-US"/>
               <a:t>Second level</a:t>
             </a:r>
           </a:p>
           <a:p>
             <a:pPr lvl="2"/>
             <a:r>
-              <a:rPr lang="en-US" smtClean="0"/>
+              <a:rPr lang="en-US"/>
               <a:t>Third level</a:t>
             </a:r>
           </a:p>
           <a:p>
             <a:pPr lvl="3"/>
             <a:r>
-              <a:rPr lang="en-US" smtClean="0"/>
+              <a:rPr lang="en-US"/>
               <a:t>Fourth level</a:t>
             </a:r>
           </a:p>
           <a:p>
             <a:pPr lvl="4"/>
             <a:r>
-              <a:rPr lang="en-US" smtClean="0"/>
+              <a:rPr lang="en-US"/>
               <a:t>Fifth level</a:t>
             </a:r>
-            <a:endParaRPr lang="en-US"/>
           </a:p>
         </p:txBody>
       </p:sp>
@@ -2243,7 +2241,7 @@
           <a:p>
             <a:pPr lvl="0"/>
             <a:r>
-              <a:rPr lang="en-US" smtClean="0"/>
+              <a:rPr lang="en-US"/>
               <a:t>Click to edit Master text styles</a:t>
             </a:r>
           </a:p>
@@ -2266,7 +2264,7 @@
           <a:p>
             <a:fld id="{5BCAD085-E8A6-8845-BD4E-CB4CCA059FC4}" type="datetimeFigureOut">
               <a:rPr lang="en-US" smtClean="0"/>
-              <a:t>1/27/13</a:t>
+              <a:t>5/5/2026</a:t>
             </a:fld>
             <a:endParaRPr lang="en-US"/>
           </a:p>
@@ -2369,10 +2367,9 @@
           </a:lstStyle>
           <a:p>
             <a:r>
-              <a:rPr lang="en-US" smtClean="0"/>
+              <a:rPr lang="en-US"/>
               <a:t>Click to edit Master title style</a:t>
             </a:r>
-            <a:endParaRPr lang="en-US"/>
           </a:p>
         </p:txBody>
       </p:sp>
@@ -2496,7 +2493,7 @@
           <a:p>
             <a:pPr lvl="0"/>
             <a:r>
-              <a:rPr lang="en-US" smtClean="0"/>
+              <a:rPr lang="en-US"/>
               <a:t>Click to edit Master text styles</a:t>
             </a:r>
           </a:p>
@@ -2519,7 +2516,7 @@
           <a:p>
             <a:fld id="{5BCAD085-E8A6-8845-BD4E-CB4CCA059FC4}" type="datetimeFigureOut">
               <a:rPr lang="en-US" smtClean="0"/>
-              <a:t>1/27/13</a:t>
+              <a:t>5/5/2026</a:t>
             </a:fld>
             <a:endParaRPr lang="en-US"/>
           </a:p>
@@ -2628,10 +2625,9 @@
           <a:lstStyle/>
           <a:p>
             <a:r>
-              <a:rPr lang="en-US" smtClean="0"/>
+              <a:rPr lang="en-US"/>
               <a:t>Click to edit Master title style</a:t>
             </a:r>
-            <a:endParaRPr lang="en-US"/>
           </a:p>
         </p:txBody>
       </p:sp>
@@ -2662,38 +2658,37 @@
           <a:p>
             <a:pPr lvl="0"/>
             <a:r>
-              <a:rPr lang="en-US" smtClean="0"/>
+              <a:rPr lang="en-US"/>
               <a:t>Click to edit Master text styles</a:t>
             </a:r>
           </a:p>
           <a:p>
             <a:pPr lvl="1"/>
             <a:r>
-              <a:rPr lang="en-US" smtClean="0"/>
+              <a:rPr lang="en-US"/>
               <a:t>Second level</a:t>
             </a:r>
           </a:p>
           <a:p>
             <a:pPr lvl="2"/>
             <a:r>
-              <a:rPr lang="en-US" smtClean="0"/>
+              <a:rPr lang="en-US"/>
               <a:t>Third level</a:t>
             </a:r>
           </a:p>
           <a:p>
             <a:pPr lvl="3"/>
             <a:r>
-              <a:rPr lang="en-US" smtClean="0"/>
+              <a:rPr lang="en-US"/>
               <a:t>Fourth level</a:t>
             </a:r>
           </a:p>
           <a:p>
             <a:pPr lvl="4"/>
             <a:r>
-              <a:rPr lang="en-US" smtClean="0"/>
+              <a:rPr lang="en-US"/>
               <a:t>Fifth level</a:t>
             </a:r>
-            <a:endParaRPr lang="en-US"/>
           </a:p>
         </p:txBody>
       </p:sp>
@@ -2732,7 +2727,7 @@
           <a:p>
             <a:fld id="{5BCAD085-E8A6-8845-BD4E-CB4CCA059FC4}" type="datetimeFigureOut">
               <a:rPr lang="en-US" smtClean="0"/>
-              <a:t>1/27/13</a:t>
+              <a:t>5/5/2026</a:t>
             </a:fld>
             <a:endParaRPr lang="en-US"/>
           </a:p>
@@ -3091,7 +3086,7 @@
 </file>
 
 <file path=ppt/slides/slide1.xml><?xml version="1.0" encoding="utf-8"?>
-<p:sld xmlns:a="http://schemas.openxmlformats.org/drawingml/2006/main" xmlns:p="http://schemas.openxmlformats.org/presentationml/2006/main" xmlns:r="http://schemas.openxmlformats.org/officeDocument/2006/relationships">
+<p:sld xmlns:a="http://schemas.openxmlformats.org/drawingml/2006/main" xmlns:r="http://schemas.openxmlformats.org/officeDocument/2006/relationships" xmlns:p="http://schemas.openxmlformats.org/presentationml/2006/main">
   <p:cSld>
     <p:bg>
       <p:bgPr>
@@ -3107,7 +3102,14 @@
         <p:cNvGrpSpPr/>
         <p:nvPr/>
       </p:nvGrpSpPr>
-      <p:grpSpPr/>
+      <p:grpSpPr>
+        <a:xfrm>
+          <a:off x="0" y="0"/>
+          <a:ext cx="0" cy="0"/>
+          <a:chOff x="0" y="0"/>
+          <a:chExt cx="0" cy="0"/>
+        </a:xfrm>
+      </p:grpSpPr>
       <p:sp>
         <p:nvSpPr>
           <p:cNvPr id="2" name="Rectangle 1"/>
@@ -3148,6 +3150,7 @@
           <a:lstStyle/>
           <a:p>
             <a:pPr algn="ctr"/>
+            <a:endParaRPr/>
           </a:p>
         </p:txBody>
       </p:sp>
@@ -3297,6 +3300,7 @@
           <a:lstStyle/>
           <a:p>
             <a:pPr algn="ctr"/>
+            <a:endParaRPr/>
           </a:p>
         </p:txBody>
       </p:sp>
@@ -3344,7 +3348,7 @@
 </file>
 
 <file path=ppt/slides/slide10.xml><?xml version="1.0" encoding="utf-8"?>
-<p:sld xmlns:a="http://schemas.openxmlformats.org/drawingml/2006/main" xmlns:p="http://schemas.openxmlformats.org/presentationml/2006/main" xmlns:r="http://schemas.openxmlformats.org/officeDocument/2006/relationships">
+<p:sld xmlns:a="http://schemas.openxmlformats.org/drawingml/2006/main" xmlns:r="http://schemas.openxmlformats.org/officeDocument/2006/relationships" xmlns:p="http://schemas.openxmlformats.org/presentationml/2006/main">
   <p:cSld>
     <p:bg>
       <p:bgPr>
@@ -3360,7 +3364,14 @@
         <p:cNvGrpSpPr/>
         <p:nvPr/>
       </p:nvGrpSpPr>
-      <p:grpSpPr/>
+      <p:grpSpPr>
+        <a:xfrm>
+          <a:off x="0" y="0"/>
+          <a:ext cx="0" cy="0"/>
+          <a:chOff x="0" y="0"/>
+          <a:chExt cx="0" cy="0"/>
+        </a:xfrm>
+      </p:grpSpPr>
       <p:sp>
         <p:nvSpPr>
           <p:cNvPr id="2" name="Rectangle 1"/>
@@ -3401,6 +3412,7 @@
           <a:lstStyle/>
           <a:p>
             <a:pPr algn="ctr"/>
+            <a:endParaRPr/>
           </a:p>
         </p:txBody>
       </p:sp>
@@ -3479,6 +3491,7 @@
           <a:lstStyle/>
           <a:p>
             <a:pPr algn="ctr"/>
+            <a:endParaRPr/>
           </a:p>
         </p:txBody>
       </p:sp>
@@ -3592,6 +3605,7 @@
           <a:lstStyle/>
           <a:p>
             <a:pPr algn="ctr"/>
+            <a:endParaRPr/>
           </a:p>
         </p:txBody>
       </p:sp>
@@ -3670,6 +3684,7 @@
           <a:lstStyle/>
           <a:p>
             <a:pPr algn="ctr"/>
+            <a:endParaRPr/>
           </a:p>
         </p:txBody>
       </p:sp>
@@ -3748,6 +3763,7 @@
           <a:lstStyle/>
           <a:p>
             <a:pPr algn="ctr"/>
+            <a:endParaRPr/>
           </a:p>
         </p:txBody>
       </p:sp>
@@ -3861,6 +3877,7 @@
           <a:lstStyle/>
           <a:p>
             <a:pPr algn="ctr"/>
+            <a:endParaRPr/>
           </a:p>
         </p:txBody>
       </p:sp>
@@ -4079,6 +4096,7 @@
           <a:lstStyle/>
           <a:p>
             <a:pPr algn="ctr"/>
+            <a:endParaRPr/>
           </a:p>
         </p:txBody>
       </p:sp>
@@ -4297,6 +4315,7 @@
           <a:lstStyle/>
           <a:p>
             <a:pPr algn="ctr"/>
+            <a:endParaRPr/>
           </a:p>
         </p:txBody>
       </p:sp>
@@ -4515,6 +4534,7 @@
           <a:lstStyle/>
           <a:p>
             <a:pPr algn="ctr"/>
+            <a:endParaRPr/>
           </a:p>
         </p:txBody>
       </p:sp>
@@ -4702,7 +4722,7 @@
 </file>
 
 <file path=ppt/slides/slide11.xml><?xml version="1.0" encoding="utf-8"?>
-<p:sld xmlns:a="http://schemas.openxmlformats.org/drawingml/2006/main" xmlns:p="http://schemas.openxmlformats.org/presentationml/2006/main" xmlns:r="http://schemas.openxmlformats.org/officeDocument/2006/relationships">
+<p:sld xmlns:a="http://schemas.openxmlformats.org/drawingml/2006/main" xmlns:r="http://schemas.openxmlformats.org/officeDocument/2006/relationships" xmlns:p="http://schemas.openxmlformats.org/presentationml/2006/main">
   <p:cSld>
     <p:bg>
       <p:bgPr>
@@ -4718,7 +4738,14 @@
         <p:cNvGrpSpPr/>
         <p:nvPr/>
       </p:nvGrpSpPr>
-      <p:grpSpPr/>
+      <p:grpSpPr>
+        <a:xfrm>
+          <a:off x="0" y="0"/>
+          <a:ext cx="0" cy="0"/>
+          <a:chOff x="0" y="0"/>
+          <a:chExt cx="0" cy="0"/>
+        </a:xfrm>
+      </p:grpSpPr>
       <p:sp>
         <p:nvSpPr>
           <p:cNvPr id="2" name="Rectangle 1"/>
@@ -4759,6 +4786,7 @@
           <a:lstStyle/>
           <a:p>
             <a:pPr algn="ctr"/>
+            <a:endParaRPr/>
           </a:p>
         </p:txBody>
       </p:sp>
@@ -4837,6 +4865,7 @@
           <a:lstStyle/>
           <a:p>
             <a:pPr algn="ctr"/>
+            <a:endParaRPr/>
           </a:p>
         </p:txBody>
       </p:sp>
@@ -4915,6 +4944,7 @@
           <a:lstStyle/>
           <a:p>
             <a:pPr algn="ctr"/>
+            <a:endParaRPr/>
           </a:p>
         </p:txBody>
       </p:sp>
@@ -4993,6 +5023,7 @@
           <a:lstStyle/>
           <a:p>
             <a:pPr algn="ctr"/>
+            <a:endParaRPr/>
           </a:p>
         </p:txBody>
       </p:sp>
@@ -5190,6 +5221,7 @@
           <a:lstStyle/>
           <a:p>
             <a:pPr algn="ctr"/>
+            <a:endParaRPr/>
           </a:p>
         </p:txBody>
       </p:sp>
@@ -5233,6 +5265,7 @@
           <a:lstStyle/>
           <a:p>
             <a:pPr algn="ctr"/>
+            <a:endParaRPr/>
           </a:p>
         </p:txBody>
       </p:sp>
@@ -5311,6 +5344,7 @@
           <a:lstStyle/>
           <a:p>
             <a:pPr algn="ctr"/>
+            <a:endParaRPr/>
           </a:p>
         </p:txBody>
       </p:sp>
@@ -5358,7 +5392,7 @@
 </file>
 
 <file path=ppt/slides/slide12.xml><?xml version="1.0" encoding="utf-8"?>
-<p:sld xmlns:a="http://schemas.openxmlformats.org/drawingml/2006/main" xmlns:p="http://schemas.openxmlformats.org/presentationml/2006/main" xmlns:r="http://schemas.openxmlformats.org/officeDocument/2006/relationships">
+<p:sld xmlns:a="http://schemas.openxmlformats.org/drawingml/2006/main" xmlns:r="http://schemas.openxmlformats.org/officeDocument/2006/relationships" xmlns:p="http://schemas.openxmlformats.org/presentationml/2006/main">
   <p:cSld>
     <p:bg>
       <p:bgPr>
@@ -5374,7 +5408,14 @@
         <p:cNvGrpSpPr/>
         <p:nvPr/>
       </p:nvGrpSpPr>
-      <p:grpSpPr/>
+      <p:grpSpPr>
+        <a:xfrm>
+          <a:off x="0" y="0"/>
+          <a:ext cx="0" cy="0"/>
+          <a:chOff x="0" y="0"/>
+          <a:chExt cx="0" cy="0"/>
+        </a:xfrm>
+      </p:grpSpPr>
       <p:sp>
         <p:nvSpPr>
           <p:cNvPr id="2" name="Rectangle 1"/>
@@ -5415,6 +5456,7 @@
           <a:lstStyle/>
           <a:p>
             <a:pPr algn="ctr"/>
+            <a:endParaRPr/>
           </a:p>
         </p:txBody>
       </p:sp>
@@ -5493,6 +5535,7 @@
           <a:lstStyle/>
           <a:p>
             <a:pPr algn="ctr"/>
+            <a:endParaRPr/>
           </a:p>
         </p:txBody>
       </p:sp>
@@ -5606,6 +5649,7 @@
           <a:lstStyle/>
           <a:p>
             <a:pPr algn="ctr"/>
+            <a:endParaRPr/>
           </a:p>
         </p:txBody>
       </p:sp>
@@ -5649,6 +5693,7 @@
           <a:lstStyle/>
           <a:p>
             <a:pPr algn="ctr"/>
+            <a:endParaRPr/>
           </a:p>
         </p:txBody>
       </p:sp>
@@ -5797,6 +5842,7 @@
           <a:lstStyle/>
           <a:p>
             <a:pPr algn="ctr"/>
+            <a:endParaRPr/>
           </a:p>
         </p:txBody>
       </p:sp>
@@ -5875,6 +5921,7 @@
           <a:lstStyle/>
           <a:p>
             <a:pPr algn="ctr"/>
+            <a:endParaRPr/>
           </a:p>
         </p:txBody>
       </p:sp>
@@ -5922,7 +5969,7 @@
 </file>
 
 <file path=ppt/slides/slide13.xml><?xml version="1.0" encoding="utf-8"?>
-<p:sld xmlns:a="http://schemas.openxmlformats.org/drawingml/2006/main" xmlns:p="http://schemas.openxmlformats.org/presentationml/2006/main" xmlns:r="http://schemas.openxmlformats.org/officeDocument/2006/relationships">
+<p:sld xmlns:a="http://schemas.openxmlformats.org/drawingml/2006/main" xmlns:r="http://schemas.openxmlformats.org/officeDocument/2006/relationships" xmlns:p="http://schemas.openxmlformats.org/presentationml/2006/main">
   <p:cSld>
     <p:bg>
       <p:bgPr>
@@ -5938,7 +5985,14 @@
         <p:cNvGrpSpPr/>
         <p:nvPr/>
       </p:nvGrpSpPr>
-      <p:grpSpPr/>
+      <p:grpSpPr>
+        <a:xfrm>
+          <a:off x="0" y="0"/>
+          <a:ext cx="0" cy="0"/>
+          <a:chOff x="0" y="0"/>
+          <a:chExt cx="0" cy="0"/>
+        </a:xfrm>
+      </p:grpSpPr>
       <p:sp>
         <p:nvSpPr>
           <p:cNvPr id="2" name="Rectangle 1"/>
@@ -5979,6 +6033,7 @@
           <a:lstStyle/>
           <a:p>
             <a:pPr algn="ctr"/>
+            <a:endParaRPr/>
           </a:p>
         </p:txBody>
       </p:sp>
@@ -6057,6 +6112,7 @@
           <a:lstStyle/>
           <a:p>
             <a:pPr algn="ctr"/>
+            <a:endParaRPr/>
           </a:p>
         </p:txBody>
       </p:sp>
@@ -6274,7 +6330,7 @@
 </file>
 
 <file path=ppt/slides/slide2.xml><?xml version="1.0" encoding="utf-8"?>
-<p:sld xmlns:a="http://schemas.openxmlformats.org/drawingml/2006/main" xmlns:p="http://schemas.openxmlformats.org/presentationml/2006/main" xmlns:r="http://schemas.openxmlformats.org/officeDocument/2006/relationships">
+<p:sld xmlns:a="http://schemas.openxmlformats.org/drawingml/2006/main" xmlns:r="http://schemas.openxmlformats.org/officeDocument/2006/relationships" xmlns:p="http://schemas.openxmlformats.org/presentationml/2006/main">
   <p:cSld>
     <p:bg>
       <p:bgPr>
@@ -6290,7 +6346,14 @@
         <p:cNvGrpSpPr/>
         <p:nvPr/>
       </p:nvGrpSpPr>
-      <p:grpSpPr/>
+      <p:grpSpPr>
+        <a:xfrm>
+          <a:off x="0" y="0"/>
+          <a:ext cx="0" cy="0"/>
+          <a:chOff x="0" y="0"/>
+          <a:chExt cx="0" cy="0"/>
+        </a:xfrm>
+      </p:grpSpPr>
       <p:sp>
         <p:nvSpPr>
           <p:cNvPr id="2" name="Rectangle 1"/>
@@ -6331,6 +6394,7 @@
           <a:lstStyle/>
           <a:p>
             <a:pPr algn="ctr"/>
+            <a:endParaRPr/>
           </a:p>
         </p:txBody>
       </p:sp>
@@ -6409,6 +6473,7 @@
           <a:lstStyle/>
           <a:p>
             <a:pPr algn="ctr"/>
+            <a:endParaRPr/>
           </a:p>
         </p:txBody>
       </p:sp>
@@ -6487,6 +6552,7 @@
           <a:lstStyle/>
           <a:p>
             <a:pPr algn="ctr"/>
+            <a:endParaRPr/>
           </a:p>
         </p:txBody>
       </p:sp>
@@ -6600,6 +6666,7 @@
           <a:lstStyle/>
           <a:p>
             <a:pPr algn="ctr"/>
+            <a:endParaRPr/>
           </a:p>
         </p:txBody>
       </p:sp>
@@ -6713,6 +6780,7 @@
           <a:lstStyle/>
           <a:p>
             <a:pPr algn="ctr"/>
+            <a:endParaRPr/>
           </a:p>
         </p:txBody>
       </p:sp>
@@ -6826,6 +6894,7 @@
           <a:lstStyle/>
           <a:p>
             <a:pPr algn="ctr"/>
+            <a:endParaRPr/>
           </a:p>
         </p:txBody>
       </p:sp>
@@ -6939,6 +7008,7 @@
           <a:lstStyle/>
           <a:p>
             <a:pPr algn="ctr"/>
+            <a:endParaRPr/>
           </a:p>
         </p:txBody>
       </p:sp>
@@ -7052,6 +7122,7 @@
           <a:lstStyle/>
           <a:p>
             <a:pPr algn="ctr"/>
+            <a:endParaRPr/>
           </a:p>
         </p:txBody>
       </p:sp>
@@ -7165,6 +7236,7 @@
           <a:lstStyle/>
           <a:p>
             <a:pPr algn="ctr"/>
+            <a:endParaRPr/>
           </a:p>
         </p:txBody>
       </p:sp>
@@ -7278,6 +7350,7 @@
           <a:lstStyle/>
           <a:p>
             <a:pPr algn="ctr"/>
+            <a:endParaRPr/>
           </a:p>
         </p:txBody>
       </p:sp>
@@ -7391,6 +7464,7 @@
           <a:lstStyle/>
           <a:p>
             <a:pPr algn="ctr"/>
+            <a:endParaRPr/>
           </a:p>
         </p:txBody>
       </p:sp>
@@ -7504,6 +7578,7 @@
           <a:lstStyle/>
           <a:p>
             <a:pPr algn="ctr"/>
+            <a:endParaRPr/>
           </a:p>
         </p:txBody>
       </p:sp>
@@ -7617,6 +7692,7 @@
           <a:lstStyle/>
           <a:p>
             <a:pPr algn="ctr"/>
+            <a:endParaRPr/>
           </a:p>
         </p:txBody>
       </p:sp>
@@ -7699,7 +7775,7 @@
 </file>
 
 <file path=ppt/slides/slide3.xml><?xml version="1.0" encoding="utf-8"?>
-<p:sld xmlns:a="http://schemas.openxmlformats.org/drawingml/2006/main" xmlns:p="http://schemas.openxmlformats.org/presentationml/2006/main" xmlns:r="http://schemas.openxmlformats.org/officeDocument/2006/relationships">
+<p:sld xmlns:a="http://schemas.openxmlformats.org/drawingml/2006/main" xmlns:r="http://schemas.openxmlformats.org/officeDocument/2006/relationships" xmlns:p="http://schemas.openxmlformats.org/presentationml/2006/main">
   <p:cSld>
     <p:bg>
       <p:bgPr>
@@ -7715,7 +7791,14 @@
         <p:cNvGrpSpPr/>
         <p:nvPr/>
       </p:nvGrpSpPr>
-      <p:grpSpPr/>
+      <p:grpSpPr>
+        <a:xfrm>
+          <a:off x="0" y="0"/>
+          <a:ext cx="0" cy="0"/>
+          <a:chOff x="0" y="0"/>
+          <a:chExt cx="0" cy="0"/>
+        </a:xfrm>
+      </p:grpSpPr>
       <p:sp>
         <p:nvSpPr>
           <p:cNvPr id="2" name="Rectangle 1"/>
@@ -7756,6 +7839,7 @@
           <a:lstStyle/>
           <a:p>
             <a:pPr algn="ctr"/>
+            <a:endParaRPr/>
           </a:p>
         </p:txBody>
       </p:sp>
@@ -7834,6 +7918,7 @@
           <a:lstStyle/>
           <a:p>
             <a:pPr algn="ctr"/>
+            <a:endParaRPr/>
           </a:p>
         </p:txBody>
       </p:sp>
@@ -7912,6 +7997,7 @@
           <a:lstStyle/>
           <a:p>
             <a:pPr algn="ctr"/>
+            <a:endParaRPr/>
           </a:p>
         </p:txBody>
       </p:sp>
@@ -7990,6 +8076,7 @@
           <a:lstStyle/>
           <a:p>
             <a:pPr algn="ctr"/>
+            <a:endParaRPr/>
           </a:p>
         </p:txBody>
       </p:sp>
@@ -8173,6 +8260,7 @@
           <a:lstStyle/>
           <a:p>
             <a:pPr algn="ctr"/>
+            <a:endParaRPr/>
           </a:p>
         </p:txBody>
       </p:sp>
@@ -8356,6 +8444,7 @@
           <a:lstStyle/>
           <a:p>
             <a:pPr algn="ctr"/>
+            <a:endParaRPr/>
           </a:p>
         </p:txBody>
       </p:sp>
@@ -8539,6 +8628,7 @@
           <a:lstStyle/>
           <a:p>
             <a:pPr algn="ctr"/>
+            <a:endParaRPr/>
           </a:p>
         </p:txBody>
       </p:sp>
@@ -8722,6 +8812,7 @@
           <a:lstStyle/>
           <a:p>
             <a:pPr algn="ctr"/>
+            <a:endParaRPr/>
           </a:p>
         </p:txBody>
       </p:sp>
@@ -8905,6 +8996,7 @@
           <a:lstStyle/>
           <a:p>
             <a:pPr algn="ctr"/>
+            <a:endParaRPr/>
           </a:p>
         </p:txBody>
       </p:sp>
@@ -9088,6 +9180,7 @@
           <a:lstStyle/>
           <a:p>
             <a:pPr algn="ctr"/>
+            <a:endParaRPr/>
           </a:p>
         </p:txBody>
       </p:sp>
@@ -9306,6 +9399,7 @@
           <a:lstStyle/>
           <a:p>
             <a:pPr algn="ctr"/>
+            <a:endParaRPr/>
           </a:p>
         </p:txBody>
       </p:sp>
@@ -9419,6 +9513,7 @@
           <a:lstStyle/>
           <a:p>
             <a:pPr algn="ctr"/>
+            <a:endParaRPr/>
           </a:p>
         </p:txBody>
       </p:sp>
@@ -9532,6 +9627,7 @@
           <a:lstStyle/>
           <a:p>
             <a:pPr algn="ctr"/>
+            <a:endParaRPr/>
           </a:p>
         </p:txBody>
       </p:sp>
@@ -9645,6 +9741,7 @@
           <a:lstStyle/>
           <a:p>
             <a:pPr algn="ctr"/>
+            <a:endParaRPr/>
           </a:p>
         </p:txBody>
       </p:sp>
@@ -9758,6 +9855,7 @@
           <a:lstStyle/>
           <a:p>
             <a:pPr algn="ctr"/>
+            <a:endParaRPr/>
           </a:p>
         </p:txBody>
       </p:sp>
@@ -9871,6 +9969,7 @@
           <a:lstStyle/>
           <a:p>
             <a:pPr algn="ctr"/>
+            <a:endParaRPr/>
           </a:p>
         </p:txBody>
       </p:sp>
@@ -9984,6 +10083,7 @@
           <a:lstStyle/>
           <a:p>
             <a:pPr algn="ctr"/>
+            <a:endParaRPr/>
           </a:p>
         </p:txBody>
       </p:sp>
@@ -10031,7 +10131,7 @@
 </file>
 
 <file path=ppt/slides/slide4.xml><?xml version="1.0" encoding="utf-8"?>
-<p:sld xmlns:a="http://schemas.openxmlformats.org/drawingml/2006/main" xmlns:p="http://schemas.openxmlformats.org/presentationml/2006/main" xmlns:r="http://schemas.openxmlformats.org/officeDocument/2006/relationships">
+<p:sld xmlns:a="http://schemas.openxmlformats.org/drawingml/2006/main" xmlns:r="http://schemas.openxmlformats.org/officeDocument/2006/relationships" xmlns:p="http://schemas.openxmlformats.org/presentationml/2006/main">
   <p:cSld>
     <p:bg>
       <p:bgPr>
@@ -10047,7 +10147,14 @@
         <p:cNvGrpSpPr/>
         <p:nvPr/>
       </p:nvGrpSpPr>
-      <p:grpSpPr/>
+      <p:grpSpPr>
+        <a:xfrm>
+          <a:off x="0" y="0"/>
+          <a:ext cx="0" cy="0"/>
+          <a:chOff x="0" y="0"/>
+          <a:chExt cx="0" cy="0"/>
+        </a:xfrm>
+      </p:grpSpPr>
       <p:sp>
         <p:nvSpPr>
           <p:cNvPr id="2" name="Rectangle 1"/>
@@ -10088,6 +10195,7 @@
           <a:lstStyle/>
           <a:p>
             <a:pPr algn="ctr"/>
+            <a:endParaRPr/>
           </a:p>
         </p:txBody>
       </p:sp>
@@ -10166,6 +10274,7 @@
           <a:lstStyle/>
           <a:p>
             <a:pPr algn="ctr"/>
+            <a:endParaRPr/>
           </a:p>
         </p:txBody>
       </p:sp>
@@ -10244,6 +10353,7 @@
           <a:lstStyle/>
           <a:p>
             <a:pPr algn="ctr"/>
+            <a:endParaRPr/>
           </a:p>
         </p:txBody>
       </p:sp>
@@ -10287,6 +10397,7 @@
           <a:lstStyle/>
           <a:p>
             <a:pPr algn="ctr"/>
+            <a:endParaRPr/>
           </a:p>
         </p:txBody>
       </p:sp>
@@ -10437,6 +10548,7 @@
           <a:lstStyle/>
           <a:p>
             <a:pPr algn="ctr"/>
+            <a:endParaRPr/>
           </a:p>
         </p:txBody>
       </p:sp>
@@ -10480,6 +10592,7 @@
           <a:lstStyle/>
           <a:p>
             <a:pPr algn="ctr"/>
+            <a:endParaRPr/>
           </a:p>
         </p:txBody>
       </p:sp>
@@ -10630,6 +10743,7 @@
           <a:lstStyle/>
           <a:p>
             <a:pPr algn="ctr"/>
+            <a:endParaRPr/>
           </a:p>
         </p:txBody>
       </p:sp>
@@ -10673,6 +10787,7 @@
           <a:lstStyle/>
           <a:p>
             <a:pPr algn="ctr"/>
+            <a:endParaRPr/>
           </a:p>
         </p:txBody>
       </p:sp>
@@ -10823,6 +10938,7 @@
           <a:lstStyle/>
           <a:p>
             <a:pPr algn="ctr"/>
+            <a:endParaRPr/>
           </a:p>
         </p:txBody>
       </p:sp>
@@ -10866,6 +10982,7 @@
           <a:lstStyle/>
           <a:p>
             <a:pPr algn="ctr"/>
+            <a:endParaRPr/>
           </a:p>
         </p:txBody>
       </p:sp>
@@ -11015,6 +11132,7 @@
           <a:lstStyle/>
           <a:p>
             <a:pPr algn="ctr"/>
+            <a:endParaRPr/>
           </a:p>
         </p:txBody>
       </p:sp>
@@ -11058,6 +11176,7 @@
           <a:lstStyle/>
           <a:p>
             <a:pPr algn="ctr"/>
+            <a:endParaRPr/>
           </a:p>
         </p:txBody>
       </p:sp>
@@ -11207,6 +11326,7 @@
           <a:lstStyle/>
           <a:p>
             <a:pPr algn="ctr"/>
+            <a:endParaRPr/>
           </a:p>
         </p:txBody>
       </p:sp>
@@ -11250,6 +11370,7 @@
           <a:lstStyle/>
           <a:p>
             <a:pPr algn="ctr"/>
+            <a:endParaRPr/>
           </a:p>
         </p:txBody>
       </p:sp>
@@ -11435,6 +11556,7 @@
           <a:lstStyle/>
           <a:p>
             <a:pPr algn="ctr"/>
+            <a:endParaRPr/>
           </a:p>
         </p:txBody>
       </p:sp>
@@ -11482,7 +11604,7 @@
 </file>
 
 <file path=ppt/slides/slide5.xml><?xml version="1.0" encoding="utf-8"?>
-<p:sld xmlns:a="http://schemas.openxmlformats.org/drawingml/2006/main" xmlns:p="http://schemas.openxmlformats.org/presentationml/2006/main" xmlns:r="http://schemas.openxmlformats.org/officeDocument/2006/relationships">
+<p:sld xmlns:a="http://schemas.openxmlformats.org/drawingml/2006/main" xmlns:r="http://schemas.openxmlformats.org/officeDocument/2006/relationships" xmlns:p="http://schemas.openxmlformats.org/presentationml/2006/main">
   <p:cSld>
     <p:bg>
       <p:bgPr>
@@ -11498,7 +11620,14 @@
         <p:cNvGrpSpPr/>
         <p:nvPr/>
       </p:nvGrpSpPr>
-      <p:grpSpPr/>
+      <p:grpSpPr>
+        <a:xfrm>
+          <a:off x="0" y="0"/>
+          <a:ext cx="0" cy="0"/>
+          <a:chOff x="0" y="0"/>
+          <a:chExt cx="0" cy="0"/>
+        </a:xfrm>
+      </p:grpSpPr>
       <p:sp>
         <p:nvSpPr>
           <p:cNvPr id="2" name="Rectangle 1"/>
@@ -11539,6 +11668,7 @@
           <a:lstStyle/>
           <a:p>
             <a:pPr algn="ctr"/>
+            <a:endParaRPr/>
           </a:p>
         </p:txBody>
       </p:sp>
@@ -11617,6 +11747,7 @@
           <a:lstStyle/>
           <a:p>
             <a:pPr algn="ctr"/>
+            <a:endParaRPr/>
           </a:p>
         </p:txBody>
       </p:sp>
@@ -11695,6 +11826,7 @@
           <a:lstStyle/>
           <a:p>
             <a:pPr algn="ctr"/>
+            <a:endParaRPr/>
           </a:p>
         </p:txBody>
       </p:sp>
@@ -11773,6 +11905,7 @@
           <a:lstStyle/>
           <a:p>
             <a:pPr algn="ctr"/>
+            <a:endParaRPr/>
           </a:p>
         </p:txBody>
       </p:sp>
@@ -11851,6 +11984,7 @@
           <a:lstStyle/>
           <a:p>
             <a:pPr algn="ctr"/>
+            <a:endParaRPr/>
           </a:p>
         </p:txBody>
       </p:sp>
@@ -12016,6 +12150,7 @@
           <a:lstStyle/>
           <a:p>
             <a:pPr algn="ctr"/>
+            <a:endParaRPr/>
           </a:p>
         </p:txBody>
       </p:sp>
@@ -12153,6 +12288,7 @@
           <a:lstStyle/>
           <a:p>
             <a:pPr algn="ctr"/>
+            <a:endParaRPr/>
           </a:p>
         </p:txBody>
       </p:sp>
@@ -12196,6 +12332,7 @@
           <a:lstStyle/>
           <a:p>
             <a:pPr algn="ctr"/>
+            <a:endParaRPr/>
           </a:p>
         </p:txBody>
       </p:sp>
@@ -12243,7 +12380,7 @@
 </file>
 
 <file path=ppt/slides/slide6.xml><?xml version="1.0" encoding="utf-8"?>
-<p:sld xmlns:a="http://schemas.openxmlformats.org/drawingml/2006/main" xmlns:p="http://schemas.openxmlformats.org/presentationml/2006/main" xmlns:r="http://schemas.openxmlformats.org/officeDocument/2006/relationships">
+<p:sld xmlns:a="http://schemas.openxmlformats.org/drawingml/2006/main" xmlns:r="http://schemas.openxmlformats.org/officeDocument/2006/relationships" xmlns:p="http://schemas.openxmlformats.org/presentationml/2006/main">
   <p:cSld>
     <p:bg>
       <p:bgPr>
@@ -12259,7 +12396,14 @@
         <p:cNvGrpSpPr/>
         <p:nvPr/>
       </p:nvGrpSpPr>
-      <p:grpSpPr/>
+      <p:grpSpPr>
+        <a:xfrm>
+          <a:off x="0" y="0"/>
+          <a:ext cx="0" cy="0"/>
+          <a:chOff x="0" y="0"/>
+          <a:chExt cx="0" cy="0"/>
+        </a:xfrm>
+      </p:grpSpPr>
       <p:sp>
         <p:nvSpPr>
           <p:cNvPr id="2" name="Rectangle 1"/>
@@ -12300,6 +12444,7 @@
           <a:lstStyle/>
           <a:p>
             <a:pPr algn="ctr"/>
+            <a:endParaRPr/>
           </a:p>
         </p:txBody>
       </p:sp>
@@ -12378,6 +12523,7 @@
           <a:lstStyle/>
           <a:p>
             <a:pPr algn="ctr"/>
+            <a:endParaRPr/>
           </a:p>
         </p:txBody>
       </p:sp>
@@ -12456,6 +12602,7 @@
           <a:lstStyle/>
           <a:p>
             <a:pPr algn="ctr"/>
+            <a:endParaRPr/>
           </a:p>
         </p:txBody>
       </p:sp>
@@ -12534,6 +12681,7 @@
           <a:lstStyle/>
           <a:p>
             <a:pPr algn="ctr"/>
+            <a:endParaRPr/>
           </a:p>
         </p:txBody>
       </p:sp>
@@ -12612,6 +12760,7 @@
           <a:lstStyle/>
           <a:p>
             <a:pPr algn="ctr"/>
+            <a:endParaRPr/>
           </a:p>
         </p:txBody>
       </p:sp>
@@ -12777,6 +12926,7 @@
           <a:lstStyle/>
           <a:p>
             <a:pPr algn="ctr"/>
+            <a:endParaRPr/>
           </a:p>
         </p:txBody>
       </p:sp>
@@ -12914,6 +13064,7 @@
           <a:lstStyle/>
           <a:p>
             <a:pPr algn="ctr"/>
+            <a:endParaRPr/>
           </a:p>
         </p:txBody>
       </p:sp>
@@ -12957,6 +13108,7 @@
           <a:lstStyle/>
           <a:p>
             <a:pPr algn="ctr"/>
+            <a:endParaRPr/>
           </a:p>
         </p:txBody>
       </p:sp>
@@ -13004,7 +13156,7 @@
 </file>
 
 <file path=ppt/slides/slide7.xml><?xml version="1.0" encoding="utf-8"?>
-<p:sld xmlns:a="http://schemas.openxmlformats.org/drawingml/2006/main" xmlns:p="http://schemas.openxmlformats.org/presentationml/2006/main" xmlns:r="http://schemas.openxmlformats.org/officeDocument/2006/relationships">
+<p:sld xmlns:a="http://schemas.openxmlformats.org/drawingml/2006/main" xmlns:r="http://schemas.openxmlformats.org/officeDocument/2006/relationships" xmlns:p="http://schemas.openxmlformats.org/presentationml/2006/main">
   <p:cSld>
     <p:bg>
       <p:bgPr>
@@ -13020,7 +13172,14 @@
         <p:cNvGrpSpPr/>
         <p:nvPr/>
       </p:nvGrpSpPr>
-      <p:grpSpPr/>
+      <p:grpSpPr>
+        <a:xfrm>
+          <a:off x="0" y="0"/>
+          <a:ext cx="0" cy="0"/>
+          <a:chOff x="0" y="0"/>
+          <a:chExt cx="0" cy="0"/>
+        </a:xfrm>
+      </p:grpSpPr>
       <p:sp>
         <p:nvSpPr>
           <p:cNvPr id="2" name="Rectangle 1"/>
@@ -13061,6 +13220,7 @@
           <a:lstStyle/>
           <a:p>
             <a:pPr algn="ctr"/>
+            <a:endParaRPr/>
           </a:p>
         </p:txBody>
       </p:sp>
@@ -13139,6 +13299,7 @@
           <a:lstStyle/>
           <a:p>
             <a:pPr algn="ctr"/>
+            <a:endParaRPr/>
           </a:p>
         </p:txBody>
       </p:sp>
@@ -13217,6 +13378,7 @@
           <a:lstStyle/>
           <a:p>
             <a:pPr algn="ctr"/>
+            <a:endParaRPr/>
           </a:p>
         </p:txBody>
       </p:sp>
@@ -13295,6 +13457,7 @@
           <a:lstStyle/>
           <a:p>
             <a:pPr algn="ctr"/>
+            <a:endParaRPr/>
           </a:p>
         </p:txBody>
       </p:sp>
@@ -13373,6 +13536,7 @@
           <a:lstStyle/>
           <a:p>
             <a:pPr algn="ctr"/>
+            <a:endParaRPr/>
           </a:p>
         </p:txBody>
       </p:sp>
@@ -13538,6 +13702,7 @@
           <a:lstStyle/>
           <a:p>
             <a:pPr algn="ctr"/>
+            <a:endParaRPr/>
           </a:p>
         </p:txBody>
       </p:sp>
@@ -13675,6 +13840,7 @@
           <a:lstStyle/>
           <a:p>
             <a:pPr algn="ctr"/>
+            <a:endParaRPr/>
           </a:p>
         </p:txBody>
       </p:sp>
@@ -13718,6 +13884,7 @@
           <a:lstStyle/>
           <a:p>
             <a:pPr algn="ctr"/>
+            <a:endParaRPr/>
           </a:p>
         </p:txBody>
       </p:sp>
@@ -13765,7 +13932,7 @@
 </file>
 
 <file path=ppt/slides/slide8.xml><?xml version="1.0" encoding="utf-8"?>
-<p:sld xmlns:a="http://schemas.openxmlformats.org/drawingml/2006/main" xmlns:p="http://schemas.openxmlformats.org/presentationml/2006/main" xmlns:r="http://schemas.openxmlformats.org/officeDocument/2006/relationships">
+<p:sld xmlns:a="http://schemas.openxmlformats.org/drawingml/2006/main" xmlns:r="http://schemas.openxmlformats.org/officeDocument/2006/relationships" xmlns:p="http://schemas.openxmlformats.org/presentationml/2006/main">
   <p:cSld>
     <p:bg>
       <p:bgPr>
@@ -13781,7 +13948,14 @@
         <p:cNvGrpSpPr/>
         <p:nvPr/>
       </p:nvGrpSpPr>
-      <p:grpSpPr/>
+      <p:grpSpPr>
+        <a:xfrm>
+          <a:off x="0" y="0"/>
+          <a:ext cx="0" cy="0"/>
+          <a:chOff x="0" y="0"/>
+          <a:chExt cx="0" cy="0"/>
+        </a:xfrm>
+      </p:grpSpPr>
       <p:sp>
         <p:nvSpPr>
           <p:cNvPr id="2" name="Rectangle 1"/>
@@ -13822,6 +13996,7 @@
           <a:lstStyle/>
           <a:p>
             <a:pPr algn="ctr"/>
+            <a:endParaRPr/>
           </a:p>
         </p:txBody>
       </p:sp>
@@ -13900,6 +14075,7 @@
           <a:lstStyle/>
           <a:p>
             <a:pPr algn="ctr"/>
+            <a:endParaRPr/>
           </a:p>
         </p:txBody>
       </p:sp>
@@ -13978,6 +14154,7 @@
           <a:lstStyle/>
           <a:p>
             <a:pPr algn="ctr"/>
+            <a:endParaRPr/>
           </a:p>
         </p:txBody>
       </p:sp>
@@ -14056,6 +14233,7 @@
           <a:lstStyle/>
           <a:p>
             <a:pPr algn="ctr"/>
+            <a:endParaRPr/>
           </a:p>
         </p:txBody>
       </p:sp>
@@ -14134,6 +14312,7 @@
           <a:lstStyle/>
           <a:p>
             <a:pPr algn="ctr"/>
+            <a:endParaRPr/>
           </a:p>
         </p:txBody>
       </p:sp>
@@ -14299,6 +14478,7 @@
           <a:lstStyle/>
           <a:p>
             <a:pPr algn="ctr"/>
+            <a:endParaRPr/>
           </a:p>
         </p:txBody>
       </p:sp>
@@ -14436,6 +14616,7 @@
           <a:lstStyle/>
           <a:p>
             <a:pPr algn="ctr"/>
+            <a:endParaRPr/>
           </a:p>
         </p:txBody>
       </p:sp>
@@ -14479,6 +14660,7 @@
           <a:lstStyle/>
           <a:p>
             <a:pPr algn="ctr"/>
+            <a:endParaRPr/>
           </a:p>
         </p:txBody>
       </p:sp>
@@ -14526,7 +14708,7 @@
 </file>
 
 <file path=ppt/slides/slide9.xml><?xml version="1.0" encoding="utf-8"?>
-<p:sld xmlns:a="http://schemas.openxmlformats.org/drawingml/2006/main" xmlns:p="http://schemas.openxmlformats.org/presentationml/2006/main" xmlns:r="http://schemas.openxmlformats.org/officeDocument/2006/relationships">
+<p:sld xmlns:a="http://schemas.openxmlformats.org/drawingml/2006/main" xmlns:r="http://schemas.openxmlformats.org/officeDocument/2006/relationships" xmlns:p="http://schemas.openxmlformats.org/presentationml/2006/main">
   <p:cSld>
     <p:bg>
       <p:bgPr>
@@ -14542,7 +14724,14 @@
         <p:cNvGrpSpPr/>
         <p:nvPr/>
       </p:nvGrpSpPr>
-      <p:grpSpPr/>
+      <p:grpSpPr>
+        <a:xfrm>
+          <a:off x="0" y="0"/>
+          <a:ext cx="0" cy="0"/>
+          <a:chOff x="0" y="0"/>
+          <a:chExt cx="0" cy="0"/>
+        </a:xfrm>
+      </p:grpSpPr>
       <p:sp>
         <p:nvSpPr>
           <p:cNvPr id="2" name="Rectangle 1"/>
@@ -14583,6 +14772,7 @@
           <a:lstStyle/>
           <a:p>
             <a:pPr algn="ctr"/>
+            <a:endParaRPr/>
           </a:p>
         </p:txBody>
       </p:sp>
@@ -14661,6 +14851,7 @@
           <a:lstStyle/>
           <a:p>
             <a:pPr algn="ctr"/>
+            <a:endParaRPr/>
           </a:p>
         </p:txBody>
       </p:sp>
@@ -14739,6 +14930,7 @@
           <a:lstStyle/>
           <a:p>
             <a:pPr algn="ctr"/>
+            <a:endParaRPr/>
           </a:p>
         </p:txBody>
       </p:sp>
@@ -14817,6 +15009,7 @@
           <a:lstStyle/>
           <a:p>
             <a:pPr algn="ctr"/>
+            <a:endParaRPr/>
           </a:p>
         </p:txBody>
       </p:sp>
@@ -14895,6 +15088,7 @@
           <a:lstStyle/>
           <a:p>
             <a:pPr algn="ctr"/>
+            <a:endParaRPr/>
           </a:p>
         </p:txBody>
       </p:sp>
@@ -15060,6 +15254,7 @@
           <a:lstStyle/>
           <a:p>
             <a:pPr algn="ctr"/>
+            <a:endParaRPr/>
           </a:p>
         </p:txBody>
       </p:sp>
@@ -15197,6 +15392,7 @@
           <a:lstStyle/>
           <a:p>
             <a:pPr algn="ctr"/>
+            <a:endParaRPr/>
           </a:p>
         </p:txBody>
       </p:sp>
@@ -15240,6 +15436,7 @@
           <a:lstStyle/>
           <a:p>
             <a:pPr algn="ctr"/>
+            <a:endParaRPr/>
           </a:p>
         </p:txBody>
       </p:sp>

</xml_diff>